<commit_message>
Added consensus sequence counts plot
</commit_message>
<xml_diff>
--- a/plots/marker_overlap/marker_overlap.pptx
+++ b/plots/marker_overlap/marker_overlap.pptx
@@ -6,6 +6,7 @@
   </p:sldMasterIdLst>
   <p:sldIdLst>
     <p:sldId id="256" r:id="rId2"/>
+    <p:sldId id="257" r:id="rId3"/>
   </p:sldIdLst>
   <p:sldSz cx="12192000" cy="6858000"/>
   <p:notesSz cx="6858000" cy="9144000"/>
@@ -115,7 +116,7 @@
 <file path=ppt/revisionInfo.xml><?xml version="1.0" encoding="utf-8"?>
 <p1510:revInfo xmlns:a="http://schemas.openxmlformats.org/drawingml/2006/main" xmlns:r="http://schemas.openxmlformats.org/officeDocument/2006/relationships" xmlns:p1510="http://schemas.microsoft.com/office/powerpoint/2015/10/main">
   <p1510:revLst>
-    <p1510:client id="{7CE17A3D-310D-4F3D-A278-8CD8D135CCC9}" v="5" dt="2025-10-13T08:21:13.674"/>
+    <p1510:client id="{EF5C07F9-1523-47B3-B4AC-368839789AC1}" v="5" dt="2026-01-13T20:37:42.628"/>
   </p1510:revLst>
 </p1510:revInfo>
 </file>
@@ -135,118 +136,6 @@
           <pc:docMk/>
           <pc:sldMk cId="1955097304" sldId="256"/>
         </pc:sldMkLst>
-        <pc:spChg chg="add mod">
-          <ac:chgData name="ROSS, ETHAN (PGR)" userId="64022231-9dc0-4c9d-8854-6af795d8551c" providerId="ADAL" clId="{7CE17A3D-310D-4F3D-A278-8CD8D135CCC9}" dt="2025-10-13T08:20:59.739" v="119" actId="1076"/>
-          <ac:spMkLst>
-            <pc:docMk/>
-            <pc:sldMk cId="1955097304" sldId="256"/>
-            <ac:spMk id="2" creationId="{D55B8276-7AEE-875D-EB5B-BE778E4683A3}"/>
-          </ac:spMkLst>
-        </pc:spChg>
-        <pc:spChg chg="add mod">
-          <ac:chgData name="ROSS, ETHAN (PGR)" userId="64022231-9dc0-4c9d-8854-6af795d8551c" providerId="ADAL" clId="{7CE17A3D-310D-4F3D-A278-8CD8D135CCC9}" dt="2025-10-13T08:21:42.058" v="125" actId="1076"/>
-          <ac:spMkLst>
-            <pc:docMk/>
-            <pc:sldMk cId="1955097304" sldId="256"/>
-            <ac:spMk id="3" creationId="{CCE6CD9F-6295-030A-6DAD-52ED6E12801C}"/>
-          </ac:spMkLst>
-        </pc:spChg>
-        <pc:spChg chg="add mod">
-          <ac:chgData name="ROSS, ETHAN (PGR)" userId="64022231-9dc0-4c9d-8854-6af795d8551c" providerId="ADAL" clId="{7CE17A3D-310D-4F3D-A278-8CD8D135CCC9}" dt="2025-10-13T08:22:02.929" v="129" actId="1076"/>
-          <ac:spMkLst>
-            <pc:docMk/>
-            <pc:sldMk cId="1955097304" sldId="256"/>
-            <ac:spMk id="4" creationId="{80E512C4-8C36-531C-6F49-5CA2419AAAA0}"/>
-          </ac:spMkLst>
-        </pc:spChg>
-        <pc:spChg chg="add mod">
-          <ac:chgData name="ROSS, ETHAN (PGR)" userId="64022231-9dc0-4c9d-8854-6af795d8551c" providerId="ADAL" clId="{7CE17A3D-310D-4F3D-A278-8CD8D135CCC9}" dt="2025-10-13T08:20:26.162" v="111" actId="1076"/>
-          <ac:spMkLst>
-            <pc:docMk/>
-            <pc:sldMk cId="1955097304" sldId="256"/>
-            <ac:spMk id="5" creationId="{8744AC5F-CD87-1A62-5CD4-41A3ACE8F427}"/>
-          </ac:spMkLst>
-        </pc:spChg>
-        <pc:spChg chg="mod">
-          <ac:chgData name="ROSS, ETHAN (PGR)" userId="64022231-9dc0-4c9d-8854-6af795d8551c" providerId="ADAL" clId="{7CE17A3D-310D-4F3D-A278-8CD8D135CCC9}" dt="2025-10-13T08:19:37.265" v="101" actId="1076"/>
-          <ac:spMkLst>
-            <pc:docMk/>
-            <pc:sldMk cId="1955097304" sldId="256"/>
-            <ac:spMk id="6" creationId="{681F467E-1A2A-4D13-BFFC-A12B2E4ABBC1}"/>
-          </ac:spMkLst>
-        </pc:spChg>
-        <pc:spChg chg="mod">
-          <ac:chgData name="ROSS, ETHAN (PGR)" userId="64022231-9dc0-4c9d-8854-6af795d8551c" providerId="ADAL" clId="{7CE17A3D-310D-4F3D-A278-8CD8D135CCC9}" dt="2025-10-13T08:20:05.663" v="107" actId="1076"/>
-          <ac:spMkLst>
-            <pc:docMk/>
-            <pc:sldMk cId="1955097304" sldId="256"/>
-            <ac:spMk id="10" creationId="{899849E5-6A0B-F31E-CE38-B42987DCDEFE}"/>
-          </ac:spMkLst>
-        </pc:spChg>
-        <pc:spChg chg="mod">
-          <ac:chgData name="ROSS, ETHAN (PGR)" userId="64022231-9dc0-4c9d-8854-6af795d8551c" providerId="ADAL" clId="{7CE17A3D-310D-4F3D-A278-8CD8D135CCC9}" dt="2025-10-13T08:21:59.937" v="128" actId="1076"/>
-          <ac:spMkLst>
-            <pc:docMk/>
-            <pc:sldMk cId="1955097304" sldId="256"/>
-            <ac:spMk id="15" creationId="{4E4966DC-7402-6FC2-8F91-8151DA62954B}"/>
-          </ac:spMkLst>
-        </pc:spChg>
-        <pc:spChg chg="mod">
-          <ac:chgData name="ROSS, ETHAN (PGR)" userId="64022231-9dc0-4c9d-8854-6af795d8551c" providerId="ADAL" clId="{7CE17A3D-310D-4F3D-A278-8CD8D135CCC9}" dt="2025-10-13T08:21:39.074" v="124" actId="1076"/>
-          <ac:spMkLst>
-            <pc:docMk/>
-            <pc:sldMk cId="1955097304" sldId="256"/>
-            <ac:spMk id="17" creationId="{6F28FF4C-0FEA-C5FD-45BA-375C431CE85A}"/>
-          </ac:spMkLst>
-        </pc:spChg>
-        <pc:spChg chg="mod">
-          <ac:chgData name="ROSS, ETHAN (PGR)" userId="64022231-9dc0-4c9d-8854-6af795d8551c" providerId="ADAL" clId="{7CE17A3D-310D-4F3D-A278-8CD8D135CCC9}" dt="2025-10-13T08:22:06.314" v="130" actId="1076"/>
-          <ac:spMkLst>
-            <pc:docMk/>
-            <pc:sldMk cId="1955097304" sldId="256"/>
-            <ac:spMk id="33" creationId="{151B2BC1-76A1-9C20-2C20-82ABCD9A5D5C}"/>
-          </ac:spMkLst>
-        </pc:spChg>
-        <pc:spChg chg="mod">
-          <ac:chgData name="ROSS, ETHAN (PGR)" userId="64022231-9dc0-4c9d-8854-6af795d8551c" providerId="ADAL" clId="{7CE17A3D-310D-4F3D-A278-8CD8D135CCC9}" dt="2025-10-13T08:21:45.614" v="126" actId="1076"/>
-          <ac:spMkLst>
-            <pc:docMk/>
-            <pc:sldMk cId="1955097304" sldId="256"/>
-            <ac:spMk id="34" creationId="{228F88D3-6A1D-8392-E5EB-DF0716296AFB}"/>
-          </ac:spMkLst>
-        </pc:spChg>
-        <pc:spChg chg="mod">
-          <ac:chgData name="ROSS, ETHAN (PGR)" userId="64022231-9dc0-4c9d-8854-6af795d8551c" providerId="ADAL" clId="{7CE17A3D-310D-4F3D-A278-8CD8D135CCC9}" dt="2025-10-13T08:22:09.429" v="131" actId="1076"/>
-          <ac:spMkLst>
-            <pc:docMk/>
-            <pc:sldMk cId="1955097304" sldId="256"/>
-            <ac:spMk id="37" creationId="{CBE1E0AC-DB9F-3D79-D3FD-03F7BF83B532}"/>
-          </ac:spMkLst>
-        </pc:spChg>
-        <pc:spChg chg="mod">
-          <ac:chgData name="ROSS, ETHAN (PGR)" userId="64022231-9dc0-4c9d-8854-6af795d8551c" providerId="ADAL" clId="{7CE17A3D-310D-4F3D-A278-8CD8D135CCC9}" dt="2025-10-13T08:21:55.361" v="127" actId="1076"/>
-          <ac:spMkLst>
-            <pc:docMk/>
-            <pc:sldMk cId="1955097304" sldId="256"/>
-            <ac:spMk id="39" creationId="{F1C6BF11-988E-F971-779A-9AAB10527CC9}"/>
-          </ac:spMkLst>
-        </pc:spChg>
-        <pc:spChg chg="mod">
-          <ac:chgData name="ROSS, ETHAN (PGR)" userId="64022231-9dc0-4c9d-8854-6af795d8551c" providerId="ADAL" clId="{7CE17A3D-310D-4F3D-A278-8CD8D135CCC9}" dt="2025-10-13T08:22:11.932" v="132" actId="1076"/>
-          <ac:spMkLst>
-            <pc:docMk/>
-            <pc:sldMk cId="1955097304" sldId="256"/>
-            <ac:spMk id="42" creationId="{D6AC37C8-A14F-0F4C-F344-67106BB3470A}"/>
-          </ac:spMkLst>
-        </pc:spChg>
-        <pc:spChg chg="mod">
-          <ac:chgData name="ROSS, ETHAN (PGR)" userId="64022231-9dc0-4c9d-8854-6af795d8551c" providerId="ADAL" clId="{7CE17A3D-310D-4F3D-A278-8CD8D135CCC9}" dt="2025-10-13T08:21:07.140" v="120" actId="2"/>
-          <ac:spMkLst>
-            <pc:docMk/>
-            <pc:sldMk cId="1955097304" sldId="256"/>
-            <ac:spMk id="47" creationId="{0F7F6C12-67DE-6511-6392-9C9C0E74059A}"/>
-          </ac:spMkLst>
-        </pc:spChg>
       </pc:sldChg>
     </pc:docChg>
   </pc:docChgLst>
@@ -263,6 +152,150 @@
           <pc:docMk/>
           <pc:sldMk cId="1955097304" sldId="256"/>
         </pc:sldMkLst>
+      </pc:sldChg>
+    </pc:docChg>
+  </pc:docChgLst>
+  <pc:docChgLst>
+    <pc:chgData name="ROSS, ETHAN (PGR)" userId="64022231-9dc0-4c9d-8854-6af795d8551c" providerId="ADAL" clId="{EF5C07F9-1523-47B3-B4AC-368839789AC1}"/>
+    <pc:docChg chg="undo custSel addSld modSld">
+      <pc:chgData name="ROSS, ETHAN (PGR)" userId="64022231-9dc0-4c9d-8854-6af795d8551c" providerId="ADAL" clId="{EF5C07F9-1523-47B3-B4AC-368839789AC1}" dt="2026-01-13T20:38:52.264" v="22" actId="207"/>
+      <pc:docMkLst>
+        <pc:docMk/>
+      </pc:docMkLst>
+      <pc:sldChg chg="addSp delSp modSp new mod">
+        <pc:chgData name="ROSS, ETHAN (PGR)" userId="64022231-9dc0-4c9d-8854-6af795d8551c" providerId="ADAL" clId="{EF5C07F9-1523-47B3-B4AC-368839789AC1}" dt="2026-01-13T20:38:52.264" v="22" actId="207"/>
+        <pc:sldMkLst>
+          <pc:docMk/>
+          <pc:sldMk cId="1383120718" sldId="257"/>
+        </pc:sldMkLst>
+        <pc:spChg chg="del">
+          <ac:chgData name="ROSS, ETHAN (PGR)" userId="64022231-9dc0-4c9d-8854-6af795d8551c" providerId="ADAL" clId="{EF5C07F9-1523-47B3-B4AC-368839789AC1}" dt="2026-01-13T20:37:28.808" v="3" actId="478"/>
+          <ac:spMkLst>
+            <pc:docMk/>
+            <pc:sldMk cId="1383120718" sldId="257"/>
+            <ac:spMk id="2" creationId="{27EC1917-31BF-86A9-F468-8B78D32FE4FB}"/>
+          </ac:spMkLst>
+        </pc:spChg>
+        <pc:spChg chg="del">
+          <ac:chgData name="ROSS, ETHAN (PGR)" userId="64022231-9dc0-4c9d-8854-6af795d8551c" providerId="ADAL" clId="{EF5C07F9-1523-47B3-B4AC-368839789AC1}" dt="2026-01-13T20:37:31.458" v="4" actId="478"/>
+          <ac:spMkLst>
+            <pc:docMk/>
+            <pc:sldMk cId="1383120718" sldId="257"/>
+            <ac:spMk id="3" creationId="{1613B888-BA10-A8DC-86D4-750EEFA32FB5}"/>
+          </ac:spMkLst>
+        </pc:spChg>
+        <pc:spChg chg="add mod">
+          <ac:chgData name="ROSS, ETHAN (PGR)" userId="64022231-9dc0-4c9d-8854-6af795d8551c" providerId="ADAL" clId="{EF5C07F9-1523-47B3-B4AC-368839789AC1}" dt="2026-01-13T20:37:20.941" v="1"/>
+          <ac:spMkLst>
+            <pc:docMk/>
+            <pc:sldMk cId="1383120718" sldId="257"/>
+            <ac:spMk id="8" creationId="{4B32DAAF-A362-2330-E908-84E551841BA3}"/>
+          </ac:spMkLst>
+        </pc:spChg>
+        <pc:spChg chg="add mod">
+          <ac:chgData name="ROSS, ETHAN (PGR)" userId="64022231-9dc0-4c9d-8854-6af795d8551c" providerId="ADAL" clId="{EF5C07F9-1523-47B3-B4AC-368839789AC1}" dt="2026-01-13T20:37:20.941" v="1"/>
+          <ac:spMkLst>
+            <pc:docMk/>
+            <pc:sldMk cId="1383120718" sldId="257"/>
+            <ac:spMk id="11" creationId="{D766189E-D0EC-3248-456B-F6E09375549F}"/>
+          </ac:spMkLst>
+        </pc:spChg>
+        <pc:spChg chg="add mod">
+          <ac:chgData name="ROSS, ETHAN (PGR)" userId="64022231-9dc0-4c9d-8854-6af795d8551c" providerId="ADAL" clId="{EF5C07F9-1523-47B3-B4AC-368839789AC1}" dt="2026-01-13T20:37:20.941" v="1"/>
+          <ac:spMkLst>
+            <pc:docMk/>
+            <pc:sldMk cId="1383120718" sldId="257"/>
+            <ac:spMk id="12" creationId="{6534E083-5ABA-7148-ECBA-EFA8A960AAC8}"/>
+          </ac:spMkLst>
+        </pc:spChg>
+        <pc:spChg chg="add mod">
+          <ac:chgData name="ROSS, ETHAN (PGR)" userId="64022231-9dc0-4c9d-8854-6af795d8551c" providerId="ADAL" clId="{EF5C07F9-1523-47B3-B4AC-368839789AC1}" dt="2026-01-13T20:37:20.941" v="1"/>
+          <ac:spMkLst>
+            <pc:docMk/>
+            <pc:sldMk cId="1383120718" sldId="257"/>
+            <ac:spMk id="13" creationId="{0F94191B-FF4D-C29F-4258-053BDE8CE898}"/>
+          </ac:spMkLst>
+        </pc:spChg>
+        <pc:spChg chg="add mod">
+          <ac:chgData name="ROSS, ETHAN (PGR)" userId="64022231-9dc0-4c9d-8854-6af795d8551c" providerId="ADAL" clId="{EF5C07F9-1523-47B3-B4AC-368839789AC1}" dt="2026-01-13T20:37:20.941" v="1"/>
+          <ac:spMkLst>
+            <pc:docMk/>
+            <pc:sldMk cId="1383120718" sldId="257"/>
+            <ac:spMk id="16" creationId="{2BF9EC8E-88F6-88C8-DFF6-DD836D9E1154}"/>
+          </ac:spMkLst>
+        </pc:spChg>
+        <pc:spChg chg="add mod">
+          <ac:chgData name="ROSS, ETHAN (PGR)" userId="64022231-9dc0-4c9d-8854-6af795d8551c" providerId="ADAL" clId="{EF5C07F9-1523-47B3-B4AC-368839789AC1}" dt="2026-01-13T20:37:20.941" v="1"/>
+          <ac:spMkLst>
+            <pc:docMk/>
+            <pc:sldMk cId="1383120718" sldId="257"/>
+            <ac:spMk id="18" creationId="{8447A7A2-8E5C-4CD3-7BA2-A0A43CD25D9A}"/>
+          </ac:spMkLst>
+        </pc:spChg>
+        <pc:spChg chg="add mod">
+          <ac:chgData name="ROSS, ETHAN (PGR)" userId="64022231-9dc0-4c9d-8854-6af795d8551c" providerId="ADAL" clId="{EF5C07F9-1523-47B3-B4AC-368839789AC1}" dt="2026-01-13T20:37:20.941" v="1"/>
+          <ac:spMkLst>
+            <pc:docMk/>
+            <pc:sldMk cId="1383120718" sldId="257"/>
+            <ac:spMk id="19" creationId="{31EF53AE-A2D0-62EF-5604-43B05554EDE3}"/>
+          </ac:spMkLst>
+        </pc:spChg>
+        <pc:spChg chg="add mod">
+          <ac:chgData name="ROSS, ETHAN (PGR)" userId="64022231-9dc0-4c9d-8854-6af795d8551c" providerId="ADAL" clId="{EF5C07F9-1523-47B3-B4AC-368839789AC1}" dt="2026-01-13T20:37:20.941" v="1"/>
+          <ac:spMkLst>
+            <pc:docMk/>
+            <pc:sldMk cId="1383120718" sldId="257"/>
+            <ac:spMk id="24" creationId="{CD1E7D50-F690-4A3B-9A08-882B86F75327}"/>
+          </ac:spMkLst>
+        </pc:spChg>
+        <pc:spChg chg="add mod">
+          <ac:chgData name="ROSS, ETHAN (PGR)" userId="64022231-9dc0-4c9d-8854-6af795d8551c" providerId="ADAL" clId="{EF5C07F9-1523-47B3-B4AC-368839789AC1}" dt="2026-01-13T20:37:20.941" v="1"/>
+          <ac:spMkLst>
+            <pc:docMk/>
+            <pc:sldMk cId="1383120718" sldId="257"/>
+            <ac:spMk id="25" creationId="{8F38B492-675A-239C-A0D1-99DB528599D9}"/>
+          </ac:spMkLst>
+        </pc:spChg>
+        <pc:spChg chg="add mod">
+          <ac:chgData name="ROSS, ETHAN (PGR)" userId="64022231-9dc0-4c9d-8854-6af795d8551c" providerId="ADAL" clId="{EF5C07F9-1523-47B3-B4AC-368839789AC1}" dt="2026-01-13T20:37:20.941" v="1"/>
+          <ac:spMkLst>
+            <pc:docMk/>
+            <pc:sldMk cId="1383120718" sldId="257"/>
+            <ac:spMk id="29" creationId="{B798115E-B7C0-F416-7E7B-2D5D5C2F0C7C}"/>
+          </ac:spMkLst>
+        </pc:spChg>
+        <pc:spChg chg="add mod">
+          <ac:chgData name="ROSS, ETHAN (PGR)" userId="64022231-9dc0-4c9d-8854-6af795d8551c" providerId="ADAL" clId="{EF5C07F9-1523-47B3-B4AC-368839789AC1}" dt="2026-01-13T20:38:52.264" v="22" actId="207"/>
+          <ac:spMkLst>
+            <pc:docMk/>
+            <pc:sldMk cId="1383120718" sldId="257"/>
+            <ac:spMk id="34" creationId="{78A7F099-E658-29F7-DC5E-D37CAC469CCF}"/>
+          </ac:spMkLst>
+        </pc:spChg>
+        <pc:spChg chg="add mod">
+          <ac:chgData name="ROSS, ETHAN (PGR)" userId="64022231-9dc0-4c9d-8854-6af795d8551c" providerId="ADAL" clId="{EF5C07F9-1523-47B3-B4AC-368839789AC1}" dt="2026-01-13T20:38:33.237" v="19" actId="207"/>
+          <ac:spMkLst>
+            <pc:docMk/>
+            <pc:sldMk cId="1383120718" sldId="257"/>
+            <ac:spMk id="35" creationId="{5194FF49-8B47-DE91-3CC4-5236BBB91F81}"/>
+          </ac:spMkLst>
+        </pc:spChg>
+        <pc:spChg chg="add mod">
+          <ac:chgData name="ROSS, ETHAN (PGR)" userId="64022231-9dc0-4c9d-8854-6af795d8551c" providerId="ADAL" clId="{EF5C07F9-1523-47B3-B4AC-368839789AC1}" dt="2026-01-13T20:38:09.477" v="17" actId="207"/>
+          <ac:spMkLst>
+            <pc:docMk/>
+            <pc:sldMk cId="1383120718" sldId="257"/>
+            <ac:spMk id="36" creationId="{231EE5BE-B5A3-D638-DE47-7B149BB3F35C}"/>
+          </ac:spMkLst>
+        </pc:spChg>
+        <pc:picChg chg="add">
+          <ac:chgData name="ROSS, ETHAN (PGR)" userId="64022231-9dc0-4c9d-8854-6af795d8551c" providerId="ADAL" clId="{EF5C07F9-1523-47B3-B4AC-368839789AC1}" dt="2026-01-13T20:37:26.072" v="2"/>
+          <ac:picMkLst>
+            <pc:docMk/>
+            <pc:sldMk cId="1383120718" sldId="257"/>
+            <ac:picMk id="33" creationId="{B149864C-F704-44F7-E115-E51B7FBA80AB}"/>
+          </ac:picMkLst>
+        </pc:picChg>
       </pc:sldChg>
     </pc:docChg>
   </pc:docChgLst>
@@ -418,7 +451,7 @@
           <a:p>
             <a:fld id="{4EEEFF7E-8984-41A6-9A89-C13D28A213CB}" type="datetimeFigureOut">
               <a:rPr lang="en-GB" smtClean="0"/>
-              <a:t>13/10/2025</a:t>
+              <a:t>11/01/2026</a:t>
             </a:fld>
             <a:endParaRPr lang="en-GB"/>
           </a:p>
@@ -618,7 +651,7 @@
           <a:p>
             <a:fld id="{4EEEFF7E-8984-41A6-9A89-C13D28A213CB}" type="datetimeFigureOut">
               <a:rPr lang="en-GB" smtClean="0"/>
-              <a:t>13/10/2025</a:t>
+              <a:t>11/01/2026</a:t>
             </a:fld>
             <a:endParaRPr lang="en-GB"/>
           </a:p>
@@ -828,7 +861,7 @@
           <a:p>
             <a:fld id="{4EEEFF7E-8984-41A6-9A89-C13D28A213CB}" type="datetimeFigureOut">
               <a:rPr lang="en-GB" smtClean="0"/>
-              <a:t>13/10/2025</a:t>
+              <a:t>11/01/2026</a:t>
             </a:fld>
             <a:endParaRPr lang="en-GB"/>
           </a:p>
@@ -1028,7 +1061,7 @@
           <a:p>
             <a:fld id="{4EEEFF7E-8984-41A6-9A89-C13D28A213CB}" type="datetimeFigureOut">
               <a:rPr lang="en-GB" smtClean="0"/>
-              <a:t>13/10/2025</a:t>
+              <a:t>11/01/2026</a:t>
             </a:fld>
             <a:endParaRPr lang="en-GB"/>
           </a:p>
@@ -1304,7 +1337,7 @@
           <a:p>
             <a:fld id="{4EEEFF7E-8984-41A6-9A89-C13D28A213CB}" type="datetimeFigureOut">
               <a:rPr lang="en-GB" smtClean="0"/>
-              <a:t>13/10/2025</a:t>
+              <a:t>11/01/2026</a:t>
             </a:fld>
             <a:endParaRPr lang="en-GB"/>
           </a:p>
@@ -1572,7 +1605,7 @@
           <a:p>
             <a:fld id="{4EEEFF7E-8984-41A6-9A89-C13D28A213CB}" type="datetimeFigureOut">
               <a:rPr lang="en-GB" smtClean="0"/>
-              <a:t>13/10/2025</a:t>
+              <a:t>11/01/2026</a:t>
             </a:fld>
             <a:endParaRPr lang="en-GB"/>
           </a:p>
@@ -1987,7 +2020,7 @@
           <a:p>
             <a:fld id="{4EEEFF7E-8984-41A6-9A89-C13D28A213CB}" type="datetimeFigureOut">
               <a:rPr lang="en-GB" smtClean="0"/>
-              <a:t>13/10/2025</a:t>
+              <a:t>11/01/2026</a:t>
             </a:fld>
             <a:endParaRPr lang="en-GB"/>
           </a:p>
@@ -2129,7 +2162,7 @@
           <a:p>
             <a:fld id="{4EEEFF7E-8984-41A6-9A89-C13D28A213CB}" type="datetimeFigureOut">
               <a:rPr lang="en-GB" smtClean="0"/>
-              <a:t>13/10/2025</a:t>
+              <a:t>11/01/2026</a:t>
             </a:fld>
             <a:endParaRPr lang="en-GB"/>
           </a:p>
@@ -2242,7 +2275,7 @@
           <a:p>
             <a:fld id="{4EEEFF7E-8984-41A6-9A89-C13D28A213CB}" type="datetimeFigureOut">
               <a:rPr lang="en-GB" smtClean="0"/>
-              <a:t>13/10/2025</a:t>
+              <a:t>11/01/2026</a:t>
             </a:fld>
             <a:endParaRPr lang="en-GB"/>
           </a:p>
@@ -2555,7 +2588,7 @@
           <a:p>
             <a:fld id="{4EEEFF7E-8984-41A6-9A89-C13D28A213CB}" type="datetimeFigureOut">
               <a:rPr lang="en-GB" smtClean="0"/>
-              <a:t>13/10/2025</a:t>
+              <a:t>11/01/2026</a:t>
             </a:fld>
             <a:endParaRPr lang="en-GB"/>
           </a:p>
@@ -2844,7 +2877,7 @@
           <a:p>
             <a:fld id="{4EEEFF7E-8984-41A6-9A89-C13D28A213CB}" type="datetimeFigureOut">
               <a:rPr lang="en-GB" smtClean="0"/>
-              <a:t>13/10/2025</a:t>
+              <a:t>11/01/2026</a:t>
             </a:fld>
             <a:endParaRPr lang="en-GB"/>
           </a:p>
@@ -3087,7 +3120,7 @@
           <a:p>
             <a:fld id="{4EEEFF7E-8984-41A6-9A89-C13D28A213CB}" type="datetimeFigureOut">
               <a:rPr lang="en-GB" smtClean="0"/>
-              <a:t>13/10/2025</a:t>
+              <a:t>11/01/2026</a:t>
             </a:fld>
             <a:endParaRPr lang="en-GB"/>
           </a:p>
@@ -4647,6 +4680,213 @@
     <p:extLst>
       <p:ext uri="{BB962C8B-B14F-4D97-AF65-F5344CB8AC3E}">
         <p14:creationId xmlns:p14="http://schemas.microsoft.com/office/powerpoint/2010/main" val="1955097304"/>
+      </p:ext>
+    </p:extLst>
+  </p:cSld>
+  <p:clrMapOvr>
+    <a:masterClrMapping/>
+  </p:clrMapOvr>
+</p:sld>
+</file>
+
+<file path=ppt/slides/slide2.xml><?xml version="1.0" encoding="utf-8"?>
+<p:sld xmlns:a="http://schemas.openxmlformats.org/drawingml/2006/main" xmlns:r="http://schemas.openxmlformats.org/officeDocument/2006/relationships" xmlns:p="http://schemas.openxmlformats.org/presentationml/2006/main">
+  <p:cSld>
+    <p:spTree>
+      <p:nvGrpSpPr>
+        <p:cNvPr id="1" name=""/>
+        <p:cNvGrpSpPr/>
+        <p:nvPr/>
+      </p:nvGrpSpPr>
+      <p:grpSpPr>
+        <a:xfrm>
+          <a:off x="0" y="0"/>
+          <a:ext cx="0" cy="0"/>
+          <a:chOff x="0" y="0"/>
+          <a:chExt cx="0" cy="0"/>
+        </a:xfrm>
+      </p:grpSpPr>
+      <p:pic>
+        <p:nvPicPr>
+          <p:cNvPr id="33" name="Picture 32">
+            <a:extLst>
+              <a:ext uri="{FF2B5EF4-FFF2-40B4-BE49-F238E27FC236}">
+                <a16:creationId xmlns:a16="http://schemas.microsoft.com/office/drawing/2014/main" id="{B149864C-F704-44F7-E115-E51B7FBA80AB}"/>
+              </a:ext>
+            </a:extLst>
+          </p:cNvPr>
+          <p:cNvPicPr>
+            <a:picLocks noChangeAspect="1"/>
+          </p:cNvPicPr>
+          <p:nvPr/>
+        </p:nvPicPr>
+        <p:blipFill>
+          <a:blip r:embed="rId2"/>
+          <a:stretch>
+            <a:fillRect/>
+          </a:stretch>
+        </p:blipFill>
+        <p:spPr>
+          <a:xfrm>
+            <a:off x="968819" y="182598"/>
+            <a:ext cx="10254361" cy="6492803"/>
+          </a:xfrm>
+          <a:prstGeom prst="rect">
+            <a:avLst/>
+          </a:prstGeom>
+        </p:spPr>
+      </p:pic>
+      <p:sp>
+        <p:nvSpPr>
+          <p:cNvPr id="34" name="Rectangle 33">
+            <a:extLst>
+              <a:ext uri="{FF2B5EF4-FFF2-40B4-BE49-F238E27FC236}">
+                <a16:creationId xmlns:a16="http://schemas.microsoft.com/office/drawing/2014/main" id="{78A7F099-E658-29F7-DC5E-D37CAC469CCF}"/>
+              </a:ext>
+            </a:extLst>
+          </p:cNvPr>
+          <p:cNvSpPr/>
+          <p:nvPr/>
+        </p:nvSpPr>
+        <p:spPr>
+          <a:xfrm>
+            <a:off x="332010" y="2403762"/>
+            <a:ext cx="914400" cy="1025237"/>
+          </a:xfrm>
+          <a:prstGeom prst="rect">
+            <a:avLst/>
+          </a:prstGeom>
+          <a:solidFill>
+            <a:srgbClr val="F7EDAF"/>
+          </a:solidFill>
+        </p:spPr>
+        <p:style>
+          <a:lnRef idx="2">
+            <a:schemeClr val="accent1">
+              <a:shade val="15000"/>
+            </a:schemeClr>
+          </a:lnRef>
+          <a:fillRef idx="1">
+            <a:schemeClr val="accent1"/>
+          </a:fillRef>
+          <a:effectRef idx="0">
+            <a:schemeClr val="accent1"/>
+          </a:effectRef>
+          <a:fontRef idx="minor">
+            <a:schemeClr val="lt1"/>
+          </a:fontRef>
+        </p:style>
+        <p:txBody>
+          <a:bodyPr rtlCol="0" anchor="ctr"/>
+          <a:lstStyle/>
+          <a:p>
+            <a:pPr algn="ctr"/>
+            <a:endParaRPr lang="en-GB"/>
+          </a:p>
+        </p:txBody>
+      </p:sp>
+      <p:sp>
+        <p:nvSpPr>
+          <p:cNvPr id="35" name="Rectangle 34">
+            <a:extLst>
+              <a:ext uri="{FF2B5EF4-FFF2-40B4-BE49-F238E27FC236}">
+                <a16:creationId xmlns:a16="http://schemas.microsoft.com/office/drawing/2014/main" id="{5194FF49-8B47-DE91-3CC4-5236BBB91F81}"/>
+              </a:ext>
+            </a:extLst>
+          </p:cNvPr>
+          <p:cNvSpPr/>
+          <p:nvPr/>
+        </p:nvSpPr>
+        <p:spPr>
+          <a:xfrm>
+            <a:off x="332010" y="3621022"/>
+            <a:ext cx="914400" cy="1025237"/>
+          </a:xfrm>
+          <a:prstGeom prst="rect">
+            <a:avLst/>
+          </a:prstGeom>
+          <a:solidFill>
+            <a:srgbClr val="E0AC6F"/>
+          </a:solidFill>
+        </p:spPr>
+        <p:style>
+          <a:lnRef idx="2">
+            <a:schemeClr val="accent1">
+              <a:shade val="15000"/>
+            </a:schemeClr>
+          </a:lnRef>
+          <a:fillRef idx="1">
+            <a:schemeClr val="accent1"/>
+          </a:fillRef>
+          <a:effectRef idx="0">
+            <a:schemeClr val="accent1"/>
+          </a:effectRef>
+          <a:fontRef idx="minor">
+            <a:schemeClr val="lt1"/>
+          </a:fontRef>
+        </p:style>
+        <p:txBody>
+          <a:bodyPr rtlCol="0" anchor="ctr"/>
+          <a:lstStyle/>
+          <a:p>
+            <a:pPr algn="ctr"/>
+            <a:endParaRPr lang="en-GB"/>
+          </a:p>
+        </p:txBody>
+      </p:sp>
+      <p:sp>
+        <p:nvSpPr>
+          <p:cNvPr id="36" name="Rectangle 35">
+            <a:extLst>
+              <a:ext uri="{FF2B5EF4-FFF2-40B4-BE49-F238E27FC236}">
+                <a16:creationId xmlns:a16="http://schemas.microsoft.com/office/drawing/2014/main" id="{231EE5BE-B5A3-D638-DE47-7B149BB3F35C}"/>
+              </a:ext>
+            </a:extLst>
+          </p:cNvPr>
+          <p:cNvSpPr/>
+          <p:nvPr/>
+        </p:nvSpPr>
+        <p:spPr>
+          <a:xfrm>
+            <a:off x="332010" y="4838282"/>
+            <a:ext cx="914400" cy="1025237"/>
+          </a:xfrm>
+          <a:prstGeom prst="rect">
+            <a:avLst/>
+          </a:prstGeom>
+          <a:solidFill>
+            <a:srgbClr val="D17D7F"/>
+          </a:solidFill>
+        </p:spPr>
+        <p:style>
+          <a:lnRef idx="2">
+            <a:schemeClr val="accent1">
+              <a:shade val="15000"/>
+            </a:schemeClr>
+          </a:lnRef>
+          <a:fillRef idx="1">
+            <a:schemeClr val="accent1"/>
+          </a:fillRef>
+          <a:effectRef idx="0">
+            <a:schemeClr val="accent1"/>
+          </a:effectRef>
+          <a:fontRef idx="minor">
+            <a:schemeClr val="lt1"/>
+          </a:fontRef>
+        </p:style>
+        <p:txBody>
+          <a:bodyPr rtlCol="0" anchor="ctr"/>
+          <a:lstStyle/>
+          <a:p>
+            <a:pPr algn="ctr"/>
+            <a:endParaRPr lang="en-GB"/>
+          </a:p>
+        </p:txBody>
+      </p:sp>
+    </p:spTree>
+    <p:extLst>
+      <p:ext uri="{BB962C8B-B14F-4D97-AF65-F5344CB8AC3E}">
+        <p14:creationId xmlns:p14="http://schemas.microsoft.com/office/powerpoint/2010/main" val="1383120718"/>
       </p:ext>
     </p:extLst>
   </p:cSld>

</xml_diff>